<commit_message>
Simplify mid-term SRS (plain language, 4 simple diagrams); remove Owner column from PPT slide 9
Co-Authored-By: Claude Opus 5.5 <noreply@anthropic.com>
</commit_message>
<xml_diff>
--- a/docs/mid-sem/TraceMap_MidSem_PPT.pptx
+++ b/docs/mid-sem/TraceMap_MidSem_PPT.pptx
@@ -13537,8 +13537,7 @@
               </a:tblPr>
               <a:tblGrid>
                 <a:gridCol w="2011680"/>
-                <a:gridCol w="7680960"/>
-                <a:gridCol w="1645920"/>
+                <a:gridCol w="9326880"/>
               </a:tblGrid>
               <a:tr h="384048">
                 <a:tc>
@@ -13610,57 +13609,6 @@
                           <a:latin typeface="Times New Roman"/>
                         </a:rPr>
                         <a:t>What is implemented</a:t>
-                      </a:r>
-                    </a:p>
-                  </a:txBody>
-                  <a:tcPr marL="73152" marR="73152" marT="36576" marB="36576" anchor="ctr">
-                    <a:lnL w="6350" cap="flat" cmpd="sng" algn="ctr">
-                      <a:solidFill>
-                        <a:srgbClr val="CCCCCC"/>
-                      </a:solidFill>
-                      <a:prstDash val="solid"/>
-                    </a:lnL>
-                    <a:lnR w="6350" cap="flat" cmpd="sng" algn="ctr">
-                      <a:solidFill>
-                        <a:srgbClr val="CCCCCC"/>
-                      </a:solidFill>
-                      <a:prstDash val="solid"/>
-                    </a:lnR>
-                    <a:lnT w="6350" cap="flat" cmpd="sng" algn="ctr">
-                      <a:solidFill>
-                        <a:srgbClr val="CCCCCC"/>
-                      </a:solidFill>
-                      <a:prstDash val="solid"/>
-                    </a:lnT>
-                    <a:lnB w="6350" cap="flat" cmpd="sng" algn="ctr">
-                      <a:solidFill>
-                        <a:srgbClr val="CCCCCC"/>
-                      </a:solidFill>
-                      <a:prstDash val="solid"/>
-                    </a:lnB>
-                    <a:solidFill>
-                      <a:srgbClr val="46B0FA"/>
-                    </a:solidFill>
-                  </a:tcPr>
-                </a:tc>
-                <a:tc>
-                  <a:txBody>
-                    <a:bodyPr wrap="square"/>
-                    <a:lstStyle/>
-                    <a:p>
-                      <a:pPr algn="l">
-                        <a:spcAft>
-                          <a:spcPts val="100"/>
-                        </a:spcAft>
-                      </a:pPr>
-                      <a:r>
-                        <a:rPr sz="1300" b="1">
-                          <a:solidFill>
-                            <a:srgbClr val="FFFFFF"/>
-                          </a:solidFill>
-                          <a:latin typeface="Times New Roman"/>
-                        </a:rPr>
-                        <a:t>Owner</a:t>
                       </a:r>
                     </a:p>
                   </a:txBody>
@@ -13798,57 +13746,6 @@
                     </a:solidFill>
                   </a:tcPr>
                 </a:tc>
-                <a:tc>
-                  <a:txBody>
-                    <a:bodyPr wrap="square"/>
-                    <a:lstStyle/>
-                    <a:p>
-                      <a:pPr algn="l">
-                        <a:spcAft>
-                          <a:spcPts val="100"/>
-                        </a:spcAft>
-                      </a:pPr>
-                      <a:r>
-                        <a:rPr sz="1250" b="0">
-                          <a:solidFill>
-                            <a:srgbClr val="333333"/>
-                          </a:solidFill>
-                          <a:latin typeface="Times New Roman"/>
-                        </a:rPr>
-                        <a:t>Kavya</a:t>
-                      </a:r>
-                    </a:p>
-                  </a:txBody>
-                  <a:tcPr marL="73152" marR="73152" marT="36576" marB="36576" anchor="ctr">
-                    <a:lnL w="6350" cap="flat" cmpd="sng" algn="ctr">
-                      <a:solidFill>
-                        <a:srgbClr val="CCCCCC"/>
-                      </a:solidFill>
-                      <a:prstDash val="solid"/>
-                    </a:lnL>
-                    <a:lnR w="6350" cap="flat" cmpd="sng" algn="ctr">
-                      <a:solidFill>
-                        <a:srgbClr val="CCCCCC"/>
-                      </a:solidFill>
-                      <a:prstDash val="solid"/>
-                    </a:lnR>
-                    <a:lnT w="6350" cap="flat" cmpd="sng" algn="ctr">
-                      <a:solidFill>
-                        <a:srgbClr val="CCCCCC"/>
-                      </a:solidFill>
-                      <a:prstDash val="solid"/>
-                    </a:lnT>
-                    <a:lnB w="6350" cap="flat" cmpd="sng" algn="ctr">
-                      <a:solidFill>
-                        <a:srgbClr val="CCCCCC"/>
-                      </a:solidFill>
-                      <a:prstDash val="solid"/>
-                    </a:lnB>
-                    <a:solidFill>
-                      <a:srgbClr val="FFFFFF"/>
-                    </a:solidFill>
-                  </a:tcPr>
-                </a:tc>
               </a:tr>
               <a:tr h="676656">
                 <a:tc>
@@ -13920,57 +13817,6 @@
                           <a:latin typeface="Times New Roman"/>
                         </a:rPr>
                         <a:t>Owners and types from 4 datasets; 4 filter lists incl. IndianList; India vendor list (23); fingerprinting, session-recording, form-reading flags</a:t>
-                      </a:r>
-                    </a:p>
-                  </a:txBody>
-                  <a:tcPr marL="73152" marR="73152" marT="36576" marB="36576" anchor="ctr">
-                    <a:lnL w="6350" cap="flat" cmpd="sng" algn="ctr">
-                      <a:solidFill>
-                        <a:srgbClr val="CCCCCC"/>
-                      </a:solidFill>
-                      <a:prstDash val="solid"/>
-                    </a:lnL>
-                    <a:lnR w="6350" cap="flat" cmpd="sng" algn="ctr">
-                      <a:solidFill>
-                        <a:srgbClr val="CCCCCC"/>
-                      </a:solidFill>
-                      <a:prstDash val="solid"/>
-                    </a:lnR>
-                    <a:lnT w="6350" cap="flat" cmpd="sng" algn="ctr">
-                      <a:solidFill>
-                        <a:srgbClr val="CCCCCC"/>
-                      </a:solidFill>
-                      <a:prstDash val="solid"/>
-                    </a:lnT>
-                    <a:lnB w="6350" cap="flat" cmpd="sng" algn="ctr">
-                      <a:solidFill>
-                        <a:srgbClr val="CCCCCC"/>
-                      </a:solidFill>
-                      <a:prstDash val="solid"/>
-                    </a:lnB>
-                    <a:solidFill>
-                      <a:srgbClr val="FFFFFF"/>
-                    </a:solidFill>
-                  </a:tcPr>
-                </a:tc>
-                <a:tc>
-                  <a:txBody>
-                    <a:bodyPr wrap="square"/>
-                    <a:lstStyle/>
-                    <a:p>
-                      <a:pPr algn="l">
-                        <a:spcAft>
-                          <a:spcPts val="100"/>
-                        </a:spcAft>
-                      </a:pPr>
-                      <a:r>
-                        <a:rPr sz="1250" b="0">
-                          <a:solidFill>
-                            <a:srgbClr val="333333"/>
-                          </a:solidFill>
-                          <a:latin typeface="Times New Roman"/>
-                        </a:rPr>
-                        <a:t>Nityavardhan</a:t>
                       </a:r>
                     </a:p>
                   </a:txBody>
@@ -14108,57 +13954,6 @@
                     </a:solidFill>
                   </a:tcPr>
                 </a:tc>
-                <a:tc>
-                  <a:txBody>
-                    <a:bodyPr wrap="square"/>
-                    <a:lstStyle/>
-                    <a:p>
-                      <a:pPr algn="l">
-                        <a:spcAft>
-                          <a:spcPts val="100"/>
-                        </a:spcAft>
-                      </a:pPr>
-                      <a:r>
-                        <a:rPr sz="1250" b="0">
-                          <a:solidFill>
-                            <a:srgbClr val="333333"/>
-                          </a:solidFill>
-                          <a:latin typeface="Times New Roman"/>
-                        </a:rPr>
-                        <a:t>Kartik</a:t>
-                      </a:r>
-                    </a:p>
-                  </a:txBody>
-                  <a:tcPr marL="73152" marR="73152" marT="36576" marB="36576" anchor="ctr">
-                    <a:lnL w="6350" cap="flat" cmpd="sng" algn="ctr">
-                      <a:solidFill>
-                        <a:srgbClr val="CCCCCC"/>
-                      </a:solidFill>
-                      <a:prstDash val="solid"/>
-                    </a:lnL>
-                    <a:lnR w="6350" cap="flat" cmpd="sng" algn="ctr">
-                      <a:solidFill>
-                        <a:srgbClr val="CCCCCC"/>
-                      </a:solidFill>
-                      <a:prstDash val="solid"/>
-                    </a:lnR>
-                    <a:lnT w="6350" cap="flat" cmpd="sng" algn="ctr">
-                      <a:solidFill>
-                        <a:srgbClr val="CCCCCC"/>
-                      </a:solidFill>
-                      <a:prstDash val="solid"/>
-                    </a:lnT>
-                    <a:lnB w="6350" cap="flat" cmpd="sng" algn="ctr">
-                      <a:solidFill>
-                        <a:srgbClr val="CCCCCC"/>
-                      </a:solidFill>
-                      <a:prstDash val="solid"/>
-                    </a:lnB>
-                    <a:solidFill>
-                      <a:srgbClr val="FFFFFF"/>
-                    </a:solidFill>
-                  </a:tcPr>
-                </a:tc>
               </a:tr>
               <a:tr h="676656">
                 <a:tc>
@@ -14230,57 +14025,6 @@
                           <a:latin typeface="Times New Roman"/>
                         </a:rPr>
                         <a:t>Two-visitor ID rule (Englehardt &amp; Narayanan 2016); per-site graph; confidence per link; same-company grouping</a:t>
-                      </a:r>
-                    </a:p>
-                  </a:txBody>
-                  <a:tcPr marL="73152" marR="73152" marT="36576" marB="36576" anchor="ctr">
-                    <a:lnL w="6350" cap="flat" cmpd="sng" algn="ctr">
-                      <a:solidFill>
-                        <a:srgbClr val="CCCCCC"/>
-                      </a:solidFill>
-                      <a:prstDash val="solid"/>
-                    </a:lnL>
-                    <a:lnR w="6350" cap="flat" cmpd="sng" algn="ctr">
-                      <a:solidFill>
-                        <a:srgbClr val="CCCCCC"/>
-                      </a:solidFill>
-                      <a:prstDash val="solid"/>
-                    </a:lnR>
-                    <a:lnT w="6350" cap="flat" cmpd="sng" algn="ctr">
-                      <a:solidFill>
-                        <a:srgbClr val="CCCCCC"/>
-                      </a:solidFill>
-                      <a:prstDash val="solid"/>
-                    </a:lnT>
-                    <a:lnB w="6350" cap="flat" cmpd="sng" algn="ctr">
-                      <a:solidFill>
-                        <a:srgbClr val="CCCCCC"/>
-                      </a:solidFill>
-                      <a:prstDash val="solid"/>
-                    </a:lnB>
-                    <a:solidFill>
-                      <a:srgbClr val="FFFFFF"/>
-                    </a:solidFill>
-                  </a:tcPr>
-                </a:tc>
-                <a:tc>
-                  <a:txBody>
-                    <a:bodyPr wrap="square"/>
-                    <a:lstStyle/>
-                    <a:p>
-                      <a:pPr algn="l">
-                        <a:spcAft>
-                          <a:spcPts val="100"/>
-                        </a:spcAft>
-                      </a:pPr>
-                      <a:r>
-                        <a:rPr sz="1250" b="0">
-                          <a:solidFill>
-                            <a:srgbClr val="333333"/>
-                          </a:solidFill>
-                          <a:latin typeface="Times New Roman"/>
-                        </a:rPr>
-                        <a:t>Krati</a:t>
                       </a:r>
                     </a:p>
                   </a:txBody>
@@ -14418,57 +14162,6 @@
                     </a:solidFill>
                   </a:tcPr>
                 </a:tc>
-                <a:tc>
-                  <a:txBody>
-                    <a:bodyPr wrap="square"/>
-                    <a:lstStyle/>
-                    <a:p>
-                      <a:pPr algn="l">
-                        <a:spcAft>
-                          <a:spcPts val="100"/>
-                        </a:spcAft>
-                      </a:pPr>
-                      <a:r>
-                        <a:rPr sz="1250" b="0">
-                          <a:solidFill>
-                            <a:srgbClr val="333333"/>
-                          </a:solidFill>
-                          <a:latin typeface="Times New Roman"/>
-                        </a:rPr>
-                        <a:t>Kartik, Kavya</a:t>
-                      </a:r>
-                    </a:p>
-                  </a:txBody>
-                  <a:tcPr marL="73152" marR="73152" marT="36576" marB="36576" anchor="ctr">
-                    <a:lnL w="6350" cap="flat" cmpd="sng" algn="ctr">
-                      <a:solidFill>
-                        <a:srgbClr val="CCCCCC"/>
-                      </a:solidFill>
-                      <a:prstDash val="solid"/>
-                    </a:lnL>
-                    <a:lnR w="6350" cap="flat" cmpd="sng" algn="ctr">
-                      <a:solidFill>
-                        <a:srgbClr val="CCCCCC"/>
-                      </a:solidFill>
-                      <a:prstDash val="solid"/>
-                    </a:lnR>
-                    <a:lnT w="6350" cap="flat" cmpd="sng" algn="ctr">
-                      <a:solidFill>
-                        <a:srgbClr val="CCCCCC"/>
-                      </a:solidFill>
-                      <a:prstDash val="solid"/>
-                    </a:lnT>
-                    <a:lnB w="6350" cap="flat" cmpd="sng" algn="ctr">
-                      <a:solidFill>
-                        <a:srgbClr val="CCCCCC"/>
-                      </a:solidFill>
-                      <a:prstDash val="solid"/>
-                    </a:lnB>
-                    <a:solidFill>
-                      <a:srgbClr val="FFFFFF"/>
-                    </a:solidFill>
-                  </a:tcPr>
-                </a:tc>
               </a:tr>
               <a:tr h="676656">
                 <a:tc>
@@ -14540,57 +14233,6 @@
                           <a:latin typeface="Times New Roman"/>
                         </a:rPr>
                         <a:t>Resumable batch runner with per-site time limit; 50-site pilot; sector report</a:t>
-                      </a:r>
-                    </a:p>
-                  </a:txBody>
-                  <a:tcPr marL="73152" marR="73152" marT="36576" marB="36576" anchor="ctr">
-                    <a:lnL w="6350" cap="flat" cmpd="sng" algn="ctr">
-                      <a:solidFill>
-                        <a:srgbClr val="CCCCCC"/>
-                      </a:solidFill>
-                      <a:prstDash val="solid"/>
-                    </a:lnL>
-                    <a:lnR w="6350" cap="flat" cmpd="sng" algn="ctr">
-                      <a:solidFill>
-                        <a:srgbClr val="CCCCCC"/>
-                      </a:solidFill>
-                      <a:prstDash val="solid"/>
-                    </a:lnR>
-                    <a:lnT w="6350" cap="flat" cmpd="sng" algn="ctr">
-                      <a:solidFill>
-                        <a:srgbClr val="CCCCCC"/>
-                      </a:solidFill>
-                      <a:prstDash val="solid"/>
-                    </a:lnT>
-                    <a:lnB w="6350" cap="flat" cmpd="sng" algn="ctr">
-                      <a:solidFill>
-                        <a:srgbClr val="CCCCCC"/>
-                      </a:solidFill>
-                      <a:prstDash val="solid"/>
-                    </a:lnB>
-                    <a:solidFill>
-                      <a:srgbClr val="FFFFFF"/>
-                    </a:solidFill>
-                  </a:tcPr>
-                </a:tc>
-                <a:tc>
-                  <a:txBody>
-                    <a:bodyPr wrap="square"/>
-                    <a:lstStyle/>
-                    <a:p>
-                      <a:pPr algn="l">
-                        <a:spcAft>
-                          <a:spcPts val="100"/>
-                        </a:spcAft>
-                      </a:pPr>
-                      <a:r>
-                        <a:rPr sz="1250" b="0">
-                          <a:solidFill>
-                            <a:srgbClr val="333333"/>
-                          </a:solidFill>
-                          <a:latin typeface="Times New Roman"/>
-                        </a:rPr>
-                        <a:t>Krati, all</a:t>
                       </a:r>
                     </a:p>
                   </a:txBody>

</xml_diff>